<commit_message>
* link to pancak2 subroutine added
</commit_message>
<xml_diff>
--- a/people/mbonisch/pre dat file format.pptx
+++ b/people/mbonisch/pre dat file format.pptx
@@ -6,15 +6,16 @@
     <p:sldMasterId id="2147483694" r:id="rId2"/>
   </p:sldMasterIdLst>
   <p:notesMasterIdLst>
-    <p:notesMasterId r:id="rId6"/>
+    <p:notesMasterId r:id="rId7"/>
   </p:notesMasterIdLst>
   <p:handoutMasterIdLst>
-    <p:handoutMasterId r:id="rId7"/>
+    <p:handoutMasterId r:id="rId8"/>
   </p:handoutMasterIdLst>
   <p:sldIdLst>
     <p:sldId id="392" r:id="rId3"/>
     <p:sldId id="399" r:id="rId4"/>
     <p:sldId id="401" r:id="rId5"/>
+    <p:sldId id="397" r:id="rId6"/>
   </p:sldIdLst>
   <p:sldSz cx="12192000" cy="6858000"/>
   <p:notesSz cx="6858000" cy="9144000"/>
@@ -216,7 +217,7 @@
               <a:rPr lang="nl-NL" smtClean="0">
                 <a:latin typeface="Arial" panose="020B0604020202020204" pitchFamily="34" charset="0"/>
               </a:rPr>
-              <a:t>15-1-2021</a:t>
+              <a:t>23-1-2021</a:t>
             </a:fld>
             <a:endParaRPr lang="nl-NL">
               <a:latin typeface="Arial" panose="020B0604020202020204" pitchFamily="34" charset="0"/>
@@ -394,7 +395,7 @@
             <a:fld id="{23C66214-DB21-4647-B5DA-0D17CA592867}" type="datetimeFigureOut">
               <a:rPr lang="nl-NL" smtClean="0"/>
               <a:pPr/>
-              <a:t>15-1-2021</a:t>
+              <a:t>23-1-2021</a:t>
             </a:fld>
             <a:endParaRPr lang="nl-NL"/>
           </a:p>
@@ -1400,7 +1401,7 @@
           <a:p>
             <a:fld id="{6C117EB3-0723-4C33-A2DC-6917C9CA571A}" type="datetime1">
               <a:rPr lang="nl-BE" smtClean="0"/>
-              <a:t>15/01/2021</a:t>
+              <a:t>23/01/2021</a:t>
             </a:fld>
             <a:endParaRPr lang="nl-NL"/>
           </a:p>
@@ -1683,7 +1684,7 @@
           <a:p>
             <a:fld id="{199819D0-E997-4D10-8966-002558C5432F}" type="datetime1">
               <a:rPr lang="nl-BE" smtClean="0"/>
-              <a:t>15/01/2021</a:t>
+              <a:t>23/01/2021</a:t>
             </a:fld>
             <a:endParaRPr lang="nl-NL"/>
           </a:p>
@@ -2013,7 +2014,7 @@
           <a:p>
             <a:fld id="{8BFC36D0-E188-499B-A063-E30C52BBA65B}" type="datetime1">
               <a:rPr lang="nl-BE" smtClean="0"/>
-              <a:t>15/01/2021</a:t>
+              <a:t>23/01/2021</a:t>
             </a:fld>
             <a:endParaRPr lang="nl-NL"/>
           </a:p>
@@ -2335,7 +2336,7 @@
           <a:p>
             <a:fld id="{30760969-739A-495B-9AC8-9E83DBD19472}" type="datetime1">
               <a:rPr lang="nl-BE" smtClean="0"/>
-              <a:t>15/01/2021</a:t>
+              <a:t>23/01/2021</a:t>
             </a:fld>
             <a:endParaRPr lang="nl-NL" dirty="0"/>
           </a:p>
@@ -2656,7 +2657,7 @@
           <a:p>
             <a:fld id="{6223A32B-624A-4D19-87A0-E1B3FD383FFA}" type="datetime1">
               <a:rPr lang="nl-BE" smtClean="0"/>
-              <a:t>15/01/2021</a:t>
+              <a:t>23/01/2021</a:t>
             </a:fld>
             <a:endParaRPr lang="nl-NL" dirty="0"/>
           </a:p>
@@ -2798,7 +2799,7 @@
           <a:p>
             <a:fld id="{715776D5-6471-4EFF-BEAC-785903B7FED9}" type="datetime1">
               <a:rPr lang="nl-BE" smtClean="0"/>
-              <a:t>15/01/2021</a:t>
+              <a:t>23/01/2021</a:t>
             </a:fld>
             <a:endParaRPr lang="nl-NL"/>
           </a:p>
@@ -3282,7 +3283,7 @@
           <a:p>
             <a:fld id="{AD85EAB7-456F-4852-B075-588A4BB01E68}" type="datetime1">
               <a:rPr lang="nl-BE" smtClean="0"/>
-              <a:t>15/01/2021</a:t>
+              <a:t>23/01/2021</a:t>
             </a:fld>
             <a:endParaRPr lang="nl-NL" dirty="0"/>
           </a:p>
@@ -3403,7 +3404,7 @@
           <a:p>
             <a:fld id="{145893D8-4D6A-4159-B2D6-5CAAABFF1A22}" type="datetime1">
               <a:rPr lang="nl-BE" smtClean="0"/>
-              <a:t>15/01/2021</a:t>
+              <a:t>23/01/2021</a:t>
             </a:fld>
             <a:endParaRPr lang="nl-NL"/>
           </a:p>
@@ -3524,7 +3525,7 @@
           <a:p>
             <a:fld id="{5D11006A-A638-4A45-BEF9-2F5A607B99F5}" type="datetime1">
               <a:rPr lang="nl-BE" smtClean="0"/>
-              <a:t>15/01/2021</a:t>
+              <a:t>23/01/2021</a:t>
             </a:fld>
             <a:endParaRPr lang="nl-NL"/>
           </a:p>
@@ -3708,7 +3709,7 @@
           <a:p>
             <a:fld id="{449E52BB-B06C-4FE4-BEA7-7AF30AE8D9B1}" type="datetime1">
               <a:rPr lang="nl-BE" smtClean="0"/>
-              <a:t>15/01/2021</a:t>
+              <a:t>23/01/2021</a:t>
             </a:fld>
             <a:endParaRPr lang="nl-NL" dirty="0"/>
           </a:p>
@@ -3995,7 +3996,7 @@
             <a:fld id="{9EB15C0D-7927-40B6-88B8-DB26DAC0C328}" type="datetime1">
               <a:rPr lang="nl-BE" smtClean="0"/>
               <a:pPr/>
-              <a:t>15/01/2021</a:t>
+              <a:t>23/01/2021</a:t>
             </a:fld>
             <a:endParaRPr lang="nl-NL" dirty="0"/>
           </a:p>
@@ -4639,7 +4640,7 @@
             <a:fld id="{16C7DC62-5684-4D3E-A4B3-94058A773A6B}" type="datetime1">
               <a:rPr lang="nl-BE" smtClean="0"/>
               <a:pPr/>
-              <a:t>15/01/2021</a:t>
+              <a:t>23/01/2021</a:t>
             </a:fld>
             <a:endParaRPr lang="nl-NL" dirty="0"/>
           </a:p>
@@ -6277,6 +6278,47 @@
           </a:p>
         </p:txBody>
       </p:sp>
+      <p:sp>
+        <p:nvSpPr>
+          <p:cNvPr id="25" name="TextBox 24">
+            <a:extLst>
+              <a:ext uri="{FF2B5EF4-FFF2-40B4-BE49-F238E27FC236}">
+                <a16:creationId xmlns:a16="http://schemas.microsoft.com/office/drawing/2014/main" id="{FC916DC2-DB32-40AD-AAA4-0A6EE6E3843B}"/>
+              </a:ext>
+            </a:extLst>
+          </p:cNvPr>
+          <p:cNvSpPr txBox="1"/>
+          <p:nvPr/>
+        </p:nvSpPr>
+        <p:spPr>
+          <a:xfrm>
+            <a:off x="8570151" y="234026"/>
+            <a:ext cx="3049233" cy="523220"/>
+          </a:xfrm>
+          <a:prstGeom prst="rect">
+            <a:avLst/>
+          </a:prstGeom>
+          <a:noFill/>
+        </p:spPr>
+        <p:txBody>
+          <a:bodyPr wrap="none" rtlCol="0">
+            <a:spAutoFit/>
+          </a:bodyPr>
+          <a:lstStyle/>
+          <a:p>
+            <a:r>
+              <a:rPr lang="en-US" sz="1400"/>
+              <a:t>See the pancak2 subroutine for how</a:t>
+            </a:r>
+          </a:p>
+          <a:p>
+            <a:r>
+              <a:rPr lang="en-US" sz="1400"/>
+              <a:t>these matrices are used!</a:t>
+            </a:r>
+          </a:p>
+        </p:txBody>
+      </p:sp>
     </p:spTree>
     <p:extLst>
       <p:ext uri="{BB962C8B-B14F-4D97-AF65-F5344CB8AC3E}">
@@ -8125,6 +8167,1283 @@
     <p:extLst>
       <p:ext uri="{BB962C8B-B14F-4D97-AF65-F5344CB8AC3E}">
         <p14:creationId xmlns:p14="http://schemas.microsoft.com/office/powerpoint/2010/main" val="3664188602"/>
+      </p:ext>
+    </p:extLst>
+  </p:cSld>
+  <p:clrMapOvr>
+    <a:masterClrMapping/>
+  </p:clrMapOvr>
+</p:sld>
+</file>
+
+<file path=ppt/slides/slide4.xml><?xml version="1.0" encoding="utf-8"?>
+<p:sld xmlns:a="http://schemas.openxmlformats.org/drawingml/2006/main" xmlns:r="http://schemas.openxmlformats.org/officeDocument/2006/relationships" xmlns:p="http://schemas.openxmlformats.org/presentationml/2006/main">
+  <p:cSld>
+    <p:spTree>
+      <p:nvGrpSpPr>
+        <p:cNvPr id="1" name=""/>
+        <p:cNvGrpSpPr/>
+        <p:nvPr/>
+      </p:nvGrpSpPr>
+      <p:grpSpPr>
+        <a:xfrm>
+          <a:off x="0" y="0"/>
+          <a:ext cx="0" cy="0"/>
+          <a:chOff x="0" y="0"/>
+          <a:chExt cx="0" cy="0"/>
+        </a:xfrm>
+      </p:grpSpPr>
+      <p:sp>
+        <p:nvSpPr>
+          <p:cNvPr id="2" name="Footer Placeholder 1">
+            <a:extLst>
+              <a:ext uri="{FF2B5EF4-FFF2-40B4-BE49-F238E27FC236}">
+                <a16:creationId xmlns:a16="http://schemas.microsoft.com/office/drawing/2014/main" id="{90AEA833-36BA-45FE-8867-9CBB9564BF44}"/>
+              </a:ext>
+            </a:extLst>
+          </p:cNvPr>
+          <p:cNvSpPr>
+            <a:spLocks noGrp="1"/>
+          </p:cNvSpPr>
+          <p:nvPr>
+            <p:ph type="ftr" sz="quarter" idx="11"/>
+          </p:nvPr>
+        </p:nvSpPr>
+        <p:spPr/>
+        <p:txBody>
+          <a:bodyPr/>
+          <a:lstStyle/>
+          <a:p>
+            <a:r>
+              <a:rPr lang="nl-NL"/>
+              <a:t>Department of Materials Engineering</a:t>
+            </a:r>
+          </a:p>
+        </p:txBody>
+      </p:sp>
+      <p:sp>
+        <p:nvSpPr>
+          <p:cNvPr id="3" name="Slide Number Placeholder 2">
+            <a:extLst>
+              <a:ext uri="{FF2B5EF4-FFF2-40B4-BE49-F238E27FC236}">
+                <a16:creationId xmlns:a16="http://schemas.microsoft.com/office/drawing/2014/main" id="{B9909418-09D7-43A9-9DC3-D7A2610B7183}"/>
+              </a:ext>
+            </a:extLst>
+          </p:cNvPr>
+          <p:cNvSpPr>
+            <a:spLocks noGrp="1"/>
+          </p:cNvSpPr>
+          <p:nvPr>
+            <p:ph type="sldNum" sz="quarter" idx="12"/>
+          </p:nvPr>
+        </p:nvSpPr>
+        <p:spPr/>
+        <p:txBody>
+          <a:bodyPr/>
+          <a:lstStyle/>
+          <a:p>
+            <a:fld id="{0A297500-7527-634B-90F4-69D0994C32B4}" type="slidenum">
+              <a:rPr lang="nl-NL" smtClean="0"/>
+              <a:t>4</a:t>
+            </a:fld>
+            <a:endParaRPr lang="nl-NL"/>
+          </a:p>
+        </p:txBody>
+      </p:sp>
+      <p:pic>
+        <p:nvPicPr>
+          <p:cNvPr id="5" name="Picture 4">
+            <a:extLst>
+              <a:ext uri="{FF2B5EF4-FFF2-40B4-BE49-F238E27FC236}">
+                <a16:creationId xmlns:a16="http://schemas.microsoft.com/office/drawing/2014/main" id="{B758B998-CFCF-4BF2-9B3E-082C73C2212E}"/>
+              </a:ext>
+            </a:extLst>
+          </p:cNvPr>
+          <p:cNvPicPr>
+            <a:picLocks noChangeAspect="1"/>
+          </p:cNvPicPr>
+          <p:nvPr/>
+        </p:nvPicPr>
+        <p:blipFill>
+          <a:blip r:embed="rId2"/>
+          <a:stretch>
+            <a:fillRect/>
+          </a:stretch>
+        </p:blipFill>
+        <p:spPr>
+          <a:xfrm>
+            <a:off x="290400" y="474662"/>
+            <a:ext cx="5743575" cy="371475"/>
+          </a:xfrm>
+          <a:prstGeom prst="rect">
+            <a:avLst/>
+          </a:prstGeom>
+        </p:spPr>
+      </p:pic>
+      <p:sp>
+        <p:nvSpPr>
+          <p:cNvPr id="6" name="TextBox 5">
+            <a:extLst>
+              <a:ext uri="{FF2B5EF4-FFF2-40B4-BE49-F238E27FC236}">
+                <a16:creationId xmlns:a16="http://schemas.microsoft.com/office/drawing/2014/main" id="{A8BD0B7C-938F-488E-B34C-7772F41C2841}"/>
+              </a:ext>
+            </a:extLst>
+          </p:cNvPr>
+          <p:cNvSpPr txBox="1"/>
+          <p:nvPr/>
+        </p:nvSpPr>
+        <p:spPr>
+          <a:xfrm>
+            <a:off x="6457776" y="446900"/>
+            <a:ext cx="3324500" cy="276999"/>
+          </a:xfrm>
+          <a:prstGeom prst="rect">
+            <a:avLst/>
+          </a:prstGeom>
+          <a:noFill/>
+        </p:spPr>
+        <p:txBody>
+          <a:bodyPr wrap="none" rtlCol="0">
+            <a:spAutoFit/>
+          </a:bodyPr>
+          <a:lstStyle/>
+          <a:p>
+            <a:r>
+              <a:rPr lang="en-US" sz="1200"/>
+              <a:t>grain (lamel) index in cluster (1,2 for ALAMEL)</a:t>
+            </a:r>
+          </a:p>
+        </p:txBody>
+      </p:sp>
+      <p:sp>
+        <p:nvSpPr>
+          <p:cNvPr id="7" name="TextBox 6">
+            <a:extLst>
+              <a:ext uri="{FF2B5EF4-FFF2-40B4-BE49-F238E27FC236}">
+                <a16:creationId xmlns:a16="http://schemas.microsoft.com/office/drawing/2014/main" id="{9072CF09-91CD-4EFE-BA20-79EC1A2DB28B}"/>
+              </a:ext>
+            </a:extLst>
+          </p:cNvPr>
+          <p:cNvSpPr txBox="1"/>
+          <p:nvPr/>
+        </p:nvSpPr>
+        <p:spPr>
+          <a:xfrm>
+            <a:off x="6457776" y="635038"/>
+            <a:ext cx="3454344" cy="276999"/>
+          </a:xfrm>
+          <a:prstGeom prst="rect">
+            <a:avLst/>
+          </a:prstGeom>
+          <a:noFill/>
+        </p:spPr>
+        <p:txBody>
+          <a:bodyPr wrap="none" rtlCol="0">
+            <a:spAutoFit/>
+          </a:bodyPr>
+          <a:lstStyle/>
+          <a:p>
+            <a:r>
+              <a:rPr lang="en-US" sz="1200"/>
+              <a:t>no of grains (lamels) in cluster (2 for ALAMEL)</a:t>
+            </a:r>
+          </a:p>
+        </p:txBody>
+      </p:sp>
+      <p:pic>
+        <p:nvPicPr>
+          <p:cNvPr id="9" name="Picture 8">
+            <a:extLst>
+              <a:ext uri="{FF2B5EF4-FFF2-40B4-BE49-F238E27FC236}">
+                <a16:creationId xmlns:a16="http://schemas.microsoft.com/office/drawing/2014/main" id="{3C09F8B3-B26B-4F9B-9453-A381E48D64DD}"/>
+              </a:ext>
+            </a:extLst>
+          </p:cNvPr>
+          <p:cNvPicPr>
+            <a:picLocks noChangeAspect="1"/>
+          </p:cNvPicPr>
+          <p:nvPr/>
+        </p:nvPicPr>
+        <p:blipFill>
+          <a:blip r:embed="rId3"/>
+          <a:stretch>
+            <a:fillRect/>
+          </a:stretch>
+        </p:blipFill>
+        <p:spPr>
+          <a:xfrm>
+            <a:off x="290400" y="889256"/>
+            <a:ext cx="5829300" cy="1400175"/>
+          </a:xfrm>
+          <a:prstGeom prst="rect">
+            <a:avLst/>
+          </a:prstGeom>
+        </p:spPr>
+      </p:pic>
+      <p:sp>
+        <p:nvSpPr>
+          <p:cNvPr id="10" name="TextBox 9">
+            <a:extLst>
+              <a:ext uri="{FF2B5EF4-FFF2-40B4-BE49-F238E27FC236}">
+                <a16:creationId xmlns:a16="http://schemas.microsoft.com/office/drawing/2014/main" id="{152A0F76-FDCC-478E-9B6A-F3C40B0DB0A1}"/>
+              </a:ext>
+            </a:extLst>
+          </p:cNvPr>
+          <p:cNvSpPr txBox="1"/>
+          <p:nvPr/>
+        </p:nvSpPr>
+        <p:spPr>
+          <a:xfrm>
+            <a:off x="6457776" y="889256"/>
+            <a:ext cx="4240263" cy="1384995"/>
+          </a:xfrm>
+          <a:prstGeom prst="rect">
+            <a:avLst/>
+          </a:prstGeom>
+          <a:noFill/>
+        </p:spPr>
+        <p:txBody>
+          <a:bodyPr wrap="none" rtlCol="0">
+            <a:spAutoFit/>
+          </a:bodyPr>
+          <a:lstStyle/>
+          <a:p>
+            <a:r>
+              <a:rPr lang="en-US" sz="1200"/>
+              <a:t>determine total number of deformation systems, store in M2</a:t>
+            </a:r>
+          </a:p>
+          <a:p>
+            <a:r>
+              <a:rPr lang="en-US" sz="1200"/>
+              <a:t>case 1: Taylor</a:t>
+            </a:r>
+          </a:p>
+          <a:p>
+            <a:r>
+              <a:rPr lang="en-US" sz="1200"/>
+              <a:t>case 2: ALAMEL</a:t>
+            </a:r>
+          </a:p>
+          <a:p>
+            <a:endParaRPr lang="en-US" sz="1200"/>
+          </a:p>
+          <a:p>
+            <a:endParaRPr lang="en-US" sz="1200"/>
+          </a:p>
+          <a:p>
+            <a:r>
+              <a:rPr lang="en-US" sz="1200"/>
+              <a:t>2 relaxations on each boundary</a:t>
+            </a:r>
+          </a:p>
+          <a:p>
+            <a:r>
+              <a:rPr lang="en-US" sz="1200"/>
+              <a:t>M12…total number of def. systems + relaxations</a:t>
+            </a:r>
+          </a:p>
+        </p:txBody>
+      </p:sp>
+      <p:pic>
+        <p:nvPicPr>
+          <p:cNvPr id="12" name="Picture 11">
+            <a:extLst>
+              <a:ext uri="{FF2B5EF4-FFF2-40B4-BE49-F238E27FC236}">
+                <a16:creationId xmlns:a16="http://schemas.microsoft.com/office/drawing/2014/main" id="{06A0A49B-97E4-406E-9243-856666AF0C89}"/>
+              </a:ext>
+            </a:extLst>
+          </p:cNvPr>
+          <p:cNvPicPr>
+            <a:picLocks noChangeAspect="1"/>
+          </p:cNvPicPr>
+          <p:nvPr/>
+        </p:nvPicPr>
+        <p:blipFill>
+          <a:blip r:embed="rId4"/>
+          <a:stretch>
+            <a:fillRect/>
+          </a:stretch>
+        </p:blipFill>
+        <p:spPr>
+          <a:xfrm>
+            <a:off x="274761" y="2296812"/>
+            <a:ext cx="7839075" cy="3790950"/>
+          </a:xfrm>
+          <a:prstGeom prst="rect">
+            <a:avLst/>
+          </a:prstGeom>
+        </p:spPr>
+      </p:pic>
+      <p:sp>
+        <p:nvSpPr>
+          <p:cNvPr id="13" name="TextBox 12">
+            <a:extLst>
+              <a:ext uri="{FF2B5EF4-FFF2-40B4-BE49-F238E27FC236}">
+                <a16:creationId xmlns:a16="http://schemas.microsoft.com/office/drawing/2014/main" id="{1079E228-B8B0-4521-90D2-68D24C354E39}"/>
+              </a:ext>
+            </a:extLst>
+          </p:cNvPr>
+          <p:cNvSpPr txBox="1"/>
+          <p:nvPr/>
+        </p:nvSpPr>
+        <p:spPr>
+          <a:xfrm>
+            <a:off x="8184948" y="2257989"/>
+            <a:ext cx="1576072" cy="276999"/>
+          </a:xfrm>
+          <a:prstGeom prst="rect">
+            <a:avLst/>
+          </a:prstGeom>
+          <a:noFill/>
+        </p:spPr>
+        <p:txBody>
+          <a:bodyPr wrap="none" rtlCol="0">
+            <a:spAutoFit/>
+          </a:bodyPr>
+          <a:lstStyle/>
+          <a:p>
+            <a:r>
+              <a:rPr lang="en-US" sz="1200"/>
+              <a:t>do only for 1st grain </a:t>
+            </a:r>
+          </a:p>
+        </p:txBody>
+      </p:sp>
+      <p:sp>
+        <p:nvSpPr>
+          <p:cNvPr id="4" name="Rectangle 3">
+            <a:extLst>
+              <a:ext uri="{FF2B5EF4-FFF2-40B4-BE49-F238E27FC236}">
+                <a16:creationId xmlns:a16="http://schemas.microsoft.com/office/drawing/2014/main" id="{E1B03883-FA2C-4145-9045-3658F5EE00D3}"/>
+              </a:ext>
+            </a:extLst>
+          </p:cNvPr>
+          <p:cNvSpPr/>
+          <p:nvPr/>
+        </p:nvSpPr>
+        <p:spPr>
+          <a:xfrm>
+            <a:off x="1387929" y="2495058"/>
+            <a:ext cx="5396592" cy="680850"/>
+          </a:xfrm>
+          <a:prstGeom prst="rect">
+            <a:avLst/>
+          </a:prstGeom>
+          <a:noFill/>
+          <a:ln>
+            <a:solidFill>
+              <a:srgbClr val="FF0000"/>
+            </a:solidFill>
+          </a:ln>
+        </p:spPr>
+        <p:style>
+          <a:lnRef idx="2">
+            <a:schemeClr val="accent1">
+              <a:shade val="50000"/>
+            </a:schemeClr>
+          </a:lnRef>
+          <a:fillRef idx="1">
+            <a:schemeClr val="accent1"/>
+          </a:fillRef>
+          <a:effectRef idx="0">
+            <a:schemeClr val="accent1"/>
+          </a:effectRef>
+          <a:fontRef idx="minor">
+            <a:schemeClr val="lt1"/>
+          </a:fontRef>
+        </p:style>
+        <p:txBody>
+          <a:bodyPr rtlCol="0" anchor="ctr"/>
+          <a:lstStyle/>
+          <a:p>
+            <a:pPr algn="ctr"/>
+            <a:endParaRPr lang="en-US"/>
+          </a:p>
+        </p:txBody>
+      </p:sp>
+      <p:sp>
+        <p:nvSpPr>
+          <p:cNvPr id="14" name="TextBox 13">
+            <a:extLst>
+              <a:ext uri="{FF2B5EF4-FFF2-40B4-BE49-F238E27FC236}">
+                <a16:creationId xmlns:a16="http://schemas.microsoft.com/office/drawing/2014/main" id="{4E7C728D-8DC0-48E7-B888-C49D732BFC06}"/>
+              </a:ext>
+            </a:extLst>
+          </p:cNvPr>
+          <p:cNvSpPr txBox="1"/>
+          <p:nvPr/>
+        </p:nvSpPr>
+        <p:spPr>
+          <a:xfrm>
+            <a:off x="6934478" y="2657226"/>
+            <a:ext cx="3286857" cy="461665"/>
+          </a:xfrm>
+          <a:prstGeom prst="rect">
+            <a:avLst/>
+          </a:prstGeom>
+          <a:noFill/>
+        </p:spPr>
+        <p:txBody>
+          <a:bodyPr wrap="square" rtlCol="0">
+            <a:spAutoFit/>
+          </a:bodyPr>
+          <a:lstStyle/>
+          <a:p>
+            <a:r>
+              <a:rPr lang="en-US" sz="1200">
+                <a:solidFill>
+                  <a:srgbClr val="FF0000"/>
+                </a:solidFill>
+              </a:rPr>
+              <a:t>see Van Houtte, Microstructures and Texture, 1988, Vols. 8 &amp; 9, pp. 313-350, eq. 29</a:t>
+            </a:r>
+          </a:p>
+        </p:txBody>
+      </p:sp>
+      <mc:AlternateContent xmlns:mc="http://schemas.openxmlformats.org/markup-compatibility/2006">
+        <mc:Choice xmlns:a14="http://schemas.microsoft.com/office/drawing/2010/main" Requires="a14">
+          <p:sp>
+            <p:nvSpPr>
+              <p:cNvPr id="8" name="TextBox 7">
+                <a:extLst>
+                  <a:ext uri="{FF2B5EF4-FFF2-40B4-BE49-F238E27FC236}">
+                    <a16:creationId xmlns:a16="http://schemas.microsoft.com/office/drawing/2014/main" id="{FCCC2C7C-B654-4266-80E4-B12895CCF632}"/>
+                  </a:ext>
+                </a:extLst>
+              </p:cNvPr>
+              <p:cNvSpPr txBox="1"/>
+              <p:nvPr/>
+            </p:nvSpPr>
+            <p:spPr>
+              <a:xfrm>
+                <a:off x="8160783" y="3742654"/>
+                <a:ext cx="2795830" cy="519566"/>
+              </a:xfrm>
+              <a:prstGeom prst="rect">
+                <a:avLst/>
+              </a:prstGeom>
+              <a:noFill/>
+            </p:spPr>
+            <p:txBody>
+              <a:bodyPr wrap="none" lIns="0" tIns="0" rIns="0" bIns="0" rtlCol="0">
+                <a:spAutoFit/>
+              </a:bodyPr>
+              <a:lstStyle/>
+              <a:p>
+                <a:pPr/>
+                <a14:m>
+                  <m:oMathPara xmlns:m="http://schemas.openxmlformats.org/officeDocument/2006/math">
+                    <m:oMathParaPr>
+                      <m:jc m:val="centerGroup"/>
+                    </m:oMathParaPr>
+                    <m:oMath xmlns:m="http://schemas.openxmlformats.org/officeDocument/2006/math">
+                      <m:r>
+                        <a:rPr lang="en-US" i="1" smtClean="0">
+                          <a:latin typeface="Cambria Math" panose="02040503050406030204" pitchFamily="18" charset="0"/>
+                        </a:rPr>
+                        <m:t>𝐴</m:t>
+                      </m:r>
+                      <m:r>
+                        <a:rPr lang="en-US" b="0" i="1" smtClean="0">
+                          <a:latin typeface="Cambria Math" panose="02040503050406030204" pitchFamily="18" charset="0"/>
+                        </a:rPr>
+                        <m:t>2</m:t>
+                      </m:r>
+                      <m:r>
+                        <a:rPr lang="en-US" i="1" smtClean="0">
+                          <a:latin typeface="Cambria Math" panose="02040503050406030204" pitchFamily="18" charset="0"/>
+                        </a:rPr>
+                        <m:t>=</m:t>
+                      </m:r>
+                      <m:d>
+                        <m:dPr>
+                          <m:begChr m:val="["/>
+                          <m:endChr m:val="]"/>
+                          <m:ctrlPr>
+                            <a:rPr lang="en-US" i="1" smtClean="0">
+                              <a:latin typeface="Cambria Math" panose="02040503050406030204" pitchFamily="18" charset="0"/>
+                            </a:rPr>
+                          </m:ctrlPr>
+                        </m:dPr>
+                        <m:e>
+                          <m:m>
+                            <m:mPr>
+                              <m:mcs>
+                                <m:mc>
+                                  <m:mcPr>
+                                    <m:count m:val="3"/>
+                                    <m:mcJc m:val="center"/>
+                                  </m:mcPr>
+                                </m:mc>
+                              </m:mcs>
+                              <m:ctrlPr>
+                                <a:rPr lang="en-US" i="1" smtClean="0">
+                                  <a:latin typeface="Cambria Math" panose="02040503050406030204" pitchFamily="18" charset="0"/>
+                                </a:rPr>
+                              </m:ctrlPr>
+                            </m:mPr>
+                            <m:mr>
+                              <m:e>
+                                <m:r>
+                                  <m:rPr>
+                                    <m:brk m:alnAt="7"/>
+                                  </m:rPr>
+                                  <a:rPr lang="en-US" b="0" i="1" smtClean="0">
+                                    <a:latin typeface="Cambria Math" panose="02040503050406030204" pitchFamily="18" charset="0"/>
+                                  </a:rPr>
+                                  <m:t>𝐴</m:t>
+                                </m:r>
+                                <m:r>
+                                  <a:rPr lang="en-US" b="0" i="1" smtClean="0">
+                                    <a:latin typeface="Cambria Math" panose="02040503050406030204" pitchFamily="18" charset="0"/>
+                                  </a:rPr>
+                                  <m:t>𝑔</m:t>
+                                </m:r>
+                                <m:r>
+                                  <a:rPr lang="en-US" b="0" i="1" smtClean="0">
+                                    <a:latin typeface="Cambria Math" panose="02040503050406030204" pitchFamily="18" charset="0"/>
+                                  </a:rPr>
+                                  <m:t>1</m:t>
+                                </m:r>
+                              </m:e>
+                              <m:e>
+                                <m:r>
+                                  <a:rPr lang="en-US" b="0" i="1" smtClean="0">
+                                    <a:latin typeface="Cambria Math" panose="02040503050406030204" pitchFamily="18" charset="0"/>
+                                  </a:rPr>
+                                  <m:t>0</m:t>
+                                </m:r>
+                              </m:e>
+                              <m:e>
+                                <m:r>
+                                  <a:rPr lang="en-US" b="0" i="1" smtClean="0">
+                                    <a:latin typeface="Cambria Math" panose="02040503050406030204" pitchFamily="18" charset="0"/>
+                                  </a:rPr>
+                                  <m:t>𝑅𝐿𝑋</m:t>
+                                </m:r>
+                                <m:r>
+                                  <a:rPr lang="en-US" b="0" i="1" smtClean="0">
+                                    <a:latin typeface="Cambria Math" panose="02040503050406030204" pitchFamily="18" charset="0"/>
+                                  </a:rPr>
+                                  <m:t>𝑔</m:t>
+                                </m:r>
+                                <m:r>
+                                  <a:rPr lang="en-US" b="0" i="1" smtClean="0">
+                                    <a:latin typeface="Cambria Math" panose="02040503050406030204" pitchFamily="18" charset="0"/>
+                                  </a:rPr>
+                                  <m:t>1</m:t>
+                                </m:r>
+                              </m:e>
+                            </m:mr>
+                            <m:mr>
+                              <m:e>
+                                <m:r>
+                                  <a:rPr lang="en-US" b="0" i="1" smtClean="0">
+                                    <a:latin typeface="Cambria Math" panose="02040503050406030204" pitchFamily="18" charset="0"/>
+                                  </a:rPr>
+                                  <m:t>0</m:t>
+                                </m:r>
+                              </m:e>
+                              <m:e>
+                                <m:r>
+                                  <a:rPr lang="en-US" b="0" i="1" smtClean="0">
+                                    <a:latin typeface="Cambria Math" panose="02040503050406030204" pitchFamily="18" charset="0"/>
+                                  </a:rPr>
+                                  <m:t>𝐴</m:t>
+                                </m:r>
+                                <m:r>
+                                  <a:rPr lang="en-US" b="0" i="1" smtClean="0">
+                                    <a:latin typeface="Cambria Math" panose="02040503050406030204" pitchFamily="18" charset="0"/>
+                                  </a:rPr>
+                                  <m:t>𝑔</m:t>
+                                </m:r>
+                                <m:r>
+                                  <a:rPr lang="en-US" b="0" i="1" smtClean="0">
+                                    <a:latin typeface="Cambria Math" panose="02040503050406030204" pitchFamily="18" charset="0"/>
+                                  </a:rPr>
+                                  <m:t>2</m:t>
+                                </m:r>
+                              </m:e>
+                              <m:e>
+                                <m:r>
+                                  <a:rPr lang="en-US" b="0" i="1" smtClean="0">
+                                    <a:latin typeface="Cambria Math" panose="02040503050406030204" pitchFamily="18" charset="0"/>
+                                  </a:rPr>
+                                  <m:t>𝑅𝐿𝑋</m:t>
+                                </m:r>
+                                <m:r>
+                                  <a:rPr lang="en-US" b="0" i="1" smtClean="0">
+                                    <a:latin typeface="Cambria Math" panose="02040503050406030204" pitchFamily="18" charset="0"/>
+                                  </a:rPr>
+                                  <m:t>𝑔</m:t>
+                                </m:r>
+                                <m:r>
+                                  <a:rPr lang="en-US" b="0" i="1" smtClean="0">
+                                    <a:latin typeface="Cambria Math" panose="02040503050406030204" pitchFamily="18" charset="0"/>
+                                  </a:rPr>
+                                  <m:t>2</m:t>
+                                </m:r>
+                              </m:e>
+                            </m:mr>
+                          </m:m>
+                        </m:e>
+                      </m:d>
+                    </m:oMath>
+                  </m:oMathPara>
+                </a14:m>
+                <a:endParaRPr lang="en-US"/>
+              </a:p>
+            </p:txBody>
+          </p:sp>
+        </mc:Choice>
+        <mc:Fallback>
+          <p:sp>
+            <p:nvSpPr>
+              <p:cNvPr id="8" name="TextBox 7">
+                <a:extLst>
+                  <a:ext uri="{FF2B5EF4-FFF2-40B4-BE49-F238E27FC236}">
+                    <a16:creationId xmlns:a16="http://schemas.microsoft.com/office/drawing/2014/main" id="{FCCC2C7C-B654-4266-80E4-B12895CCF632}"/>
+                  </a:ext>
+                </a:extLst>
+              </p:cNvPr>
+              <p:cNvSpPr txBox="1">
+                <a:spLocks noRot="1" noChangeAspect="1" noMove="1" noResize="1" noEditPoints="1" noAdjustHandles="1" noChangeArrowheads="1" noChangeShapeType="1" noTextEdit="1"/>
+              </p:cNvSpPr>
+              <p:nvPr/>
+            </p:nvSpPr>
+            <p:spPr>
+              <a:xfrm>
+                <a:off x="8160783" y="3742654"/>
+                <a:ext cx="2795830" cy="519566"/>
+              </a:xfrm>
+              <a:prstGeom prst="rect">
+                <a:avLst/>
+              </a:prstGeom>
+              <a:blipFill>
+                <a:blip r:embed="rId5"/>
+                <a:stretch>
+                  <a:fillRect b="-1176"/>
+                </a:stretch>
+              </a:blipFill>
+            </p:spPr>
+            <p:txBody>
+              <a:bodyPr/>
+              <a:lstStyle/>
+              <a:p>
+                <a:r>
+                  <a:rPr lang="en-US">
+                    <a:noFill/>
+                  </a:rPr>
+                  <a:t> </a:t>
+                </a:r>
+              </a:p>
+            </p:txBody>
+          </p:sp>
+        </mc:Fallback>
+      </mc:AlternateContent>
+      <p:sp>
+        <p:nvSpPr>
+          <p:cNvPr id="15" name="TextBox 14">
+            <a:extLst>
+              <a:ext uri="{FF2B5EF4-FFF2-40B4-BE49-F238E27FC236}">
+                <a16:creationId xmlns:a16="http://schemas.microsoft.com/office/drawing/2014/main" id="{B66E912D-F153-43BC-A1AB-19D0DD594B09}"/>
+              </a:ext>
+            </a:extLst>
+          </p:cNvPr>
+          <p:cNvSpPr txBox="1"/>
+          <p:nvPr/>
+        </p:nvSpPr>
+        <p:spPr>
+          <a:xfrm>
+            <a:off x="8319197" y="4414201"/>
+            <a:ext cx="3752502" cy="276999"/>
+          </a:xfrm>
+          <a:prstGeom prst="rect">
+            <a:avLst/>
+          </a:prstGeom>
+          <a:noFill/>
+        </p:spPr>
+        <p:txBody>
+          <a:bodyPr wrap="none" rtlCol="0">
+            <a:spAutoFit/>
+          </a:bodyPr>
+          <a:lstStyle/>
+          <a:p>
+            <a:r>
+              <a:rPr lang="en-US" sz="1200"/>
+              <a:t>Ag1 and Ag2 are [5x5], RLXg1 and RLXg2 are [5x2] </a:t>
+            </a:r>
+          </a:p>
+        </p:txBody>
+      </p:sp>
+      <p:cxnSp>
+        <p:nvCxnSpPr>
+          <p:cNvPr id="17" name="Straight Arrow Connector 16">
+            <a:extLst>
+              <a:ext uri="{FF2B5EF4-FFF2-40B4-BE49-F238E27FC236}">
+                <a16:creationId xmlns:a16="http://schemas.microsoft.com/office/drawing/2014/main" id="{66D912BD-6139-4444-B253-2C979664ADDC}"/>
+              </a:ext>
+            </a:extLst>
+          </p:cNvPr>
+          <p:cNvCxnSpPr/>
+          <p:nvPr/>
+        </p:nvCxnSpPr>
+        <p:spPr>
+          <a:xfrm>
+            <a:off x="11069139" y="3739110"/>
+            <a:ext cx="0" cy="453177"/>
+          </a:xfrm>
+          <a:prstGeom prst="straightConnector1">
+            <a:avLst/>
+          </a:prstGeom>
+          <a:ln>
+            <a:tailEnd type="triangle"/>
+          </a:ln>
+        </p:spPr>
+        <p:style>
+          <a:lnRef idx="1">
+            <a:schemeClr val="accent1"/>
+          </a:lnRef>
+          <a:fillRef idx="0">
+            <a:schemeClr val="accent1"/>
+          </a:fillRef>
+          <a:effectRef idx="0">
+            <a:schemeClr val="accent1"/>
+          </a:effectRef>
+          <a:fontRef idx="minor">
+            <a:schemeClr val="tx1"/>
+          </a:fontRef>
+        </p:style>
+      </p:cxnSp>
+      <p:cxnSp>
+        <p:nvCxnSpPr>
+          <p:cNvPr id="19" name="Straight Arrow Connector 18">
+            <a:extLst>
+              <a:ext uri="{FF2B5EF4-FFF2-40B4-BE49-F238E27FC236}">
+                <a16:creationId xmlns:a16="http://schemas.microsoft.com/office/drawing/2014/main" id="{44052A27-25E6-4EFB-A12E-E1F9AF2B57DB}"/>
+              </a:ext>
+            </a:extLst>
+          </p:cNvPr>
+          <p:cNvCxnSpPr/>
+          <p:nvPr/>
+        </p:nvCxnSpPr>
+        <p:spPr>
+          <a:xfrm>
+            <a:off x="8923565" y="3600445"/>
+            <a:ext cx="1714500" cy="0"/>
+          </a:xfrm>
+          <a:prstGeom prst="straightConnector1">
+            <a:avLst/>
+          </a:prstGeom>
+          <a:ln>
+            <a:tailEnd type="triangle"/>
+          </a:ln>
+        </p:spPr>
+        <p:style>
+          <a:lnRef idx="1">
+            <a:schemeClr val="accent1"/>
+          </a:lnRef>
+          <a:fillRef idx="0">
+            <a:schemeClr val="accent1"/>
+          </a:fillRef>
+          <a:effectRef idx="0">
+            <a:schemeClr val="accent1"/>
+          </a:effectRef>
+          <a:fontRef idx="minor">
+            <a:schemeClr val="tx1"/>
+          </a:fontRef>
+        </p:style>
+      </p:cxnSp>
+      <p:sp>
+        <p:nvSpPr>
+          <p:cNvPr id="20" name="TextBox 19">
+            <a:extLst>
+              <a:ext uri="{FF2B5EF4-FFF2-40B4-BE49-F238E27FC236}">
+                <a16:creationId xmlns:a16="http://schemas.microsoft.com/office/drawing/2014/main" id="{BC80FD37-5207-4D61-B1EB-975D5CC8D4B8}"/>
+              </a:ext>
+            </a:extLst>
+          </p:cNvPr>
+          <p:cNvSpPr txBox="1"/>
+          <p:nvPr/>
+        </p:nvSpPr>
+        <p:spPr>
+          <a:xfrm>
+            <a:off x="11192847" y="3771604"/>
+            <a:ext cx="1078032" cy="461665"/>
+          </a:xfrm>
+          <a:prstGeom prst="rect">
+            <a:avLst/>
+          </a:prstGeom>
+          <a:noFill/>
+        </p:spPr>
+        <p:txBody>
+          <a:bodyPr wrap="square" rtlCol="0">
+            <a:spAutoFit/>
+          </a:bodyPr>
+          <a:lstStyle/>
+          <a:p>
+            <a:r>
+              <a:rPr lang="en-US" sz="1200"/>
+              <a:t>grain 1</a:t>
+            </a:r>
+          </a:p>
+          <a:p>
+            <a:r>
+              <a:rPr lang="en-US" sz="1200"/>
+              <a:t>grain 2</a:t>
+            </a:r>
+          </a:p>
+        </p:txBody>
+      </p:sp>
+      <p:sp>
+        <p:nvSpPr>
+          <p:cNvPr id="21" name="TextBox 20">
+            <a:extLst>
+              <a:ext uri="{FF2B5EF4-FFF2-40B4-BE49-F238E27FC236}">
+                <a16:creationId xmlns:a16="http://schemas.microsoft.com/office/drawing/2014/main" id="{82F9A434-8A66-4C97-8AD9-221518A127D0}"/>
+              </a:ext>
+            </a:extLst>
+          </p:cNvPr>
+          <p:cNvSpPr txBox="1"/>
+          <p:nvPr/>
+        </p:nvSpPr>
+        <p:spPr>
+          <a:xfrm>
+            <a:off x="8623934" y="3147827"/>
+            <a:ext cx="2313762" cy="461665"/>
+          </a:xfrm>
+          <a:prstGeom prst="rect">
+            <a:avLst/>
+          </a:prstGeom>
+          <a:noFill/>
+        </p:spPr>
+        <p:txBody>
+          <a:bodyPr wrap="square" rtlCol="0">
+            <a:spAutoFit/>
+          </a:bodyPr>
+          <a:lstStyle/>
+          <a:p>
+            <a:pPr algn="ctr"/>
+            <a:r>
+              <a:rPr lang="en-US" sz="1200"/>
+              <a:t>each column is a basis vector in 5-dim strain space</a:t>
+            </a:r>
+          </a:p>
+        </p:txBody>
+      </p:sp>
+      <mc:AlternateContent xmlns:mc="http://schemas.openxmlformats.org/markup-compatibility/2006">
+        <mc:Choice xmlns:a14="http://schemas.microsoft.com/office/drawing/2010/main" Requires="a14">
+          <p:sp>
+            <p:nvSpPr>
+              <p:cNvPr id="22" name="TextBox 21">
+                <a:extLst>
+                  <a:ext uri="{FF2B5EF4-FFF2-40B4-BE49-F238E27FC236}">
+                    <a16:creationId xmlns:a16="http://schemas.microsoft.com/office/drawing/2014/main" id="{D6F99DED-5664-41FE-8C8E-F30BE3E7F989}"/>
+                  </a:ext>
+                </a:extLst>
+              </p:cNvPr>
+              <p:cNvSpPr txBox="1"/>
+              <p:nvPr/>
+            </p:nvSpPr>
+            <p:spPr>
+              <a:xfrm>
+                <a:off x="9280439" y="5128292"/>
+                <a:ext cx="1129668" cy="276999"/>
+              </a:xfrm>
+              <a:prstGeom prst="rect">
+                <a:avLst/>
+              </a:prstGeom>
+              <a:noFill/>
+            </p:spPr>
+            <p:txBody>
+              <a:bodyPr wrap="none" lIns="0" tIns="0" rIns="0" bIns="0" rtlCol="0">
+                <a:spAutoFit/>
+              </a:bodyPr>
+              <a:lstStyle/>
+              <a:p>
+                <a:pPr/>
+                <a14:m>
+                  <m:oMathPara xmlns:m="http://schemas.openxmlformats.org/officeDocument/2006/math">
+                    <m:oMathParaPr>
+                      <m:jc m:val="centerGroup"/>
+                    </m:oMathParaPr>
+                    <m:oMath xmlns:m="http://schemas.openxmlformats.org/officeDocument/2006/math">
+                      <m:r>
+                        <a:rPr lang="en-US" i="1" smtClean="0">
+                          <a:latin typeface="Cambria Math" panose="02040503050406030204" pitchFamily="18" charset="0"/>
+                        </a:rPr>
+                        <m:t>𝐴</m:t>
+                      </m:r>
+                      <m:r>
+                        <a:rPr lang="en-US" b="0" i="1" smtClean="0">
+                          <a:latin typeface="Cambria Math" panose="02040503050406030204" pitchFamily="18" charset="0"/>
+                        </a:rPr>
+                        <m:t>2</m:t>
+                      </m:r>
+                      <m:r>
+                        <a:rPr lang="en-US" i="1" smtClean="0">
+                          <a:latin typeface="Cambria Math" panose="02040503050406030204" pitchFamily="18" charset="0"/>
+                          <a:ea typeface="Cambria Math" panose="02040503050406030204" pitchFamily="18" charset="0"/>
+                        </a:rPr>
+                        <m:t>∙</m:t>
+                      </m:r>
+                      <m:r>
+                        <a:rPr lang="en-US" b="0" i="1" smtClean="0">
+                          <a:latin typeface="Cambria Math" panose="02040503050406030204" pitchFamily="18" charset="0"/>
+                          <a:ea typeface="Cambria Math" panose="02040503050406030204" pitchFamily="18" charset="0"/>
+                        </a:rPr>
+                        <m:t>𝑋</m:t>
+                      </m:r>
+                      <m:r>
+                        <a:rPr lang="en-US" b="0" i="1" smtClean="0">
+                          <a:latin typeface="Cambria Math" panose="02040503050406030204" pitchFamily="18" charset="0"/>
+                          <a:ea typeface="Cambria Math" panose="02040503050406030204" pitchFamily="18" charset="0"/>
+                        </a:rPr>
+                        <m:t>=</m:t>
+                      </m:r>
+                      <m:r>
+                        <a:rPr lang="en-US" b="0" i="1" smtClean="0">
+                          <a:latin typeface="Cambria Math" panose="02040503050406030204" pitchFamily="18" charset="0"/>
+                          <a:ea typeface="Cambria Math" panose="02040503050406030204" pitchFamily="18" charset="0"/>
+                        </a:rPr>
+                        <m:t>𝐷</m:t>
+                      </m:r>
+                    </m:oMath>
+                  </m:oMathPara>
+                </a14:m>
+                <a:endParaRPr lang="en-US"/>
+              </a:p>
+            </p:txBody>
+          </p:sp>
+        </mc:Choice>
+        <mc:Fallback>
+          <p:sp>
+            <p:nvSpPr>
+              <p:cNvPr id="22" name="TextBox 21">
+                <a:extLst>
+                  <a:ext uri="{FF2B5EF4-FFF2-40B4-BE49-F238E27FC236}">
+                    <a16:creationId xmlns:a16="http://schemas.microsoft.com/office/drawing/2014/main" id="{D6F99DED-5664-41FE-8C8E-F30BE3E7F989}"/>
+                  </a:ext>
+                </a:extLst>
+              </p:cNvPr>
+              <p:cNvSpPr txBox="1">
+                <a:spLocks noRot="1" noChangeAspect="1" noMove="1" noResize="1" noEditPoints="1" noAdjustHandles="1" noChangeArrowheads="1" noChangeShapeType="1" noTextEdit="1"/>
+              </p:cNvSpPr>
+              <p:nvPr/>
+            </p:nvSpPr>
+            <p:spPr>
+              <a:xfrm>
+                <a:off x="9280439" y="5128292"/>
+                <a:ext cx="1129668" cy="276999"/>
+              </a:xfrm>
+              <a:prstGeom prst="rect">
+                <a:avLst/>
+              </a:prstGeom>
+              <a:blipFill>
+                <a:blip r:embed="rId6"/>
+                <a:stretch>
+                  <a:fillRect l="-3763" r="-3226" b="-8696"/>
+                </a:stretch>
+              </a:blipFill>
+            </p:spPr>
+            <p:txBody>
+              <a:bodyPr/>
+              <a:lstStyle/>
+              <a:p>
+                <a:r>
+                  <a:rPr lang="en-US">
+                    <a:noFill/>
+                  </a:rPr>
+                  <a:t> </a:t>
+                </a:r>
+              </a:p>
+            </p:txBody>
+          </p:sp>
+        </mc:Fallback>
+      </mc:AlternateContent>
+      <p:sp>
+        <p:nvSpPr>
+          <p:cNvPr id="23" name="TextBox 22">
+            <a:extLst>
+              <a:ext uri="{FF2B5EF4-FFF2-40B4-BE49-F238E27FC236}">
+                <a16:creationId xmlns:a16="http://schemas.microsoft.com/office/drawing/2014/main" id="{C12DBE32-3B99-456D-9641-25388C07B535}"/>
+              </a:ext>
+            </a:extLst>
+          </p:cNvPr>
+          <p:cNvSpPr txBox="1"/>
+          <p:nvPr/>
+        </p:nvSpPr>
+        <p:spPr>
+          <a:xfrm>
+            <a:off x="8319197" y="4813054"/>
+            <a:ext cx="2887906" cy="276999"/>
+          </a:xfrm>
+          <a:prstGeom prst="rect">
+            <a:avLst/>
+          </a:prstGeom>
+          <a:noFill/>
+        </p:spPr>
+        <p:txBody>
+          <a:bodyPr wrap="none" rtlCol="0">
+            <a:spAutoFit/>
+          </a:bodyPr>
+          <a:lstStyle/>
+          <a:p>
+            <a:r>
+              <a:rPr lang="en-US" sz="1200"/>
+              <a:t>Equation to be solved (Taylor equation):</a:t>
+            </a:r>
+          </a:p>
+        </p:txBody>
+      </p:sp>
+      <p:sp>
+        <p:nvSpPr>
+          <p:cNvPr id="24" name="TextBox 23">
+            <a:extLst>
+              <a:ext uri="{FF2B5EF4-FFF2-40B4-BE49-F238E27FC236}">
+                <a16:creationId xmlns:a16="http://schemas.microsoft.com/office/drawing/2014/main" id="{9F7C468A-DC47-4342-AE38-694B6F70A978}"/>
+              </a:ext>
+            </a:extLst>
+          </p:cNvPr>
+          <p:cNvSpPr txBox="1"/>
+          <p:nvPr/>
+        </p:nvSpPr>
+        <p:spPr>
+          <a:xfrm>
+            <a:off x="8317067" y="5527529"/>
+            <a:ext cx="2149948" cy="461665"/>
+          </a:xfrm>
+          <a:prstGeom prst="rect">
+            <a:avLst/>
+          </a:prstGeom>
+          <a:noFill/>
+        </p:spPr>
+        <p:txBody>
+          <a:bodyPr wrap="none" rtlCol="0">
+            <a:spAutoFit/>
+          </a:bodyPr>
+          <a:lstStyle/>
+          <a:p>
+            <a:r>
+              <a:rPr lang="en-US" sz="1200"/>
+              <a:t>D…macro strain rate [10x1]</a:t>
+            </a:r>
+          </a:p>
+          <a:p>
+            <a:r>
+              <a:rPr lang="en-US" sz="1200"/>
+              <a:t>X…vector of slip rates [12x1]</a:t>
+            </a:r>
+          </a:p>
+        </p:txBody>
+      </p:sp>
+      <p:sp>
+        <p:nvSpPr>
+          <p:cNvPr id="25" name="Content Placeholder 3">
+            <a:extLst>
+              <a:ext uri="{FF2B5EF4-FFF2-40B4-BE49-F238E27FC236}">
+                <a16:creationId xmlns:a16="http://schemas.microsoft.com/office/drawing/2014/main" id="{CA8FD7E4-950A-4A03-A1D3-A40BB8629A0C}"/>
+              </a:ext>
+            </a:extLst>
+          </p:cNvPr>
+          <p:cNvSpPr txBox="1">
+            <a:spLocks/>
+          </p:cNvSpPr>
+          <p:nvPr/>
+        </p:nvSpPr>
+        <p:spPr>
+          <a:xfrm>
+            <a:off x="313498" y="-11447"/>
+            <a:ext cx="3433001" cy="484654"/>
+          </a:xfrm>
+          <a:prstGeom prst="rect">
+            <a:avLst/>
+          </a:prstGeom>
+        </p:spPr>
+        <p:txBody>
+          <a:bodyPr vert="horz" lIns="91440" tIns="45720" rIns="91440" bIns="45720" rtlCol="0">
+            <a:noAutofit/>
+          </a:bodyPr>
+          <a:lstStyle>
+            <a:lvl1pPr marL="228600" indent="-228600" algn="l" defTabSz="914400" rtl="0" eaLnBrk="1" latinLnBrk="0" hangingPunct="1">
+              <a:lnSpc>
+                <a:spcPct val="100000"/>
+              </a:lnSpc>
+              <a:spcBef>
+                <a:spcPts val="1000"/>
+              </a:spcBef>
+              <a:buFont typeface="Arial" panose="020B0604020202020204" pitchFamily="34" charset="0"/>
+              <a:buChar char="•"/>
+              <a:defRPr sz="2400" kern="1200">
+                <a:solidFill>
+                  <a:schemeClr val="tx1"/>
+                </a:solidFill>
+                <a:latin typeface="+mn-lt"/>
+                <a:ea typeface="+mn-ea"/>
+                <a:cs typeface="+mn-cs"/>
+              </a:defRPr>
+            </a:lvl1pPr>
+            <a:lvl2pPr marL="685800" indent="-228600" algn="l" defTabSz="914400" rtl="0" eaLnBrk="1" latinLnBrk="0" hangingPunct="1">
+              <a:lnSpc>
+                <a:spcPct val="100000"/>
+              </a:lnSpc>
+              <a:spcBef>
+                <a:spcPts val="500"/>
+              </a:spcBef>
+              <a:buFont typeface="Arial" panose="020B0604020202020204" pitchFamily="34" charset="0"/>
+              <a:buChar char="•"/>
+              <a:defRPr sz="2400" kern="1200">
+                <a:solidFill>
+                  <a:schemeClr val="tx1"/>
+                </a:solidFill>
+                <a:latin typeface="+mn-lt"/>
+                <a:ea typeface="+mn-ea"/>
+                <a:cs typeface="+mn-cs"/>
+              </a:defRPr>
+            </a:lvl2pPr>
+            <a:lvl3pPr marL="1143000" indent="-228600" algn="l" defTabSz="914400" rtl="0" eaLnBrk="1" latinLnBrk="0" hangingPunct="1">
+              <a:lnSpc>
+                <a:spcPct val="100000"/>
+              </a:lnSpc>
+              <a:spcBef>
+                <a:spcPts val="500"/>
+              </a:spcBef>
+              <a:buFont typeface="Arial" panose="020B0604020202020204" pitchFamily="34" charset="0"/>
+              <a:buChar char="•"/>
+              <a:defRPr sz="2000" kern="1200">
+                <a:solidFill>
+                  <a:schemeClr val="tx1"/>
+                </a:solidFill>
+                <a:latin typeface="+mn-lt"/>
+                <a:ea typeface="+mn-ea"/>
+                <a:cs typeface="+mn-cs"/>
+              </a:defRPr>
+            </a:lvl3pPr>
+            <a:lvl4pPr marL="1600200" indent="-228600" algn="l" defTabSz="914400" rtl="0" eaLnBrk="1" latinLnBrk="0" hangingPunct="1">
+              <a:lnSpc>
+                <a:spcPct val="100000"/>
+              </a:lnSpc>
+              <a:spcBef>
+                <a:spcPts val="500"/>
+              </a:spcBef>
+              <a:buFont typeface="Arial" panose="020B0604020202020204" pitchFamily="34" charset="0"/>
+              <a:buChar char="•"/>
+              <a:defRPr sz="1800" kern="1200">
+                <a:solidFill>
+                  <a:schemeClr val="tx1"/>
+                </a:solidFill>
+                <a:latin typeface="+mn-lt"/>
+                <a:ea typeface="+mn-ea"/>
+                <a:cs typeface="+mn-cs"/>
+              </a:defRPr>
+            </a:lvl4pPr>
+            <a:lvl5pPr marL="2057400" indent="-228600" algn="l" defTabSz="914400" rtl="0" eaLnBrk="1" latinLnBrk="0" hangingPunct="1">
+              <a:lnSpc>
+                <a:spcPct val="100000"/>
+              </a:lnSpc>
+              <a:spcBef>
+                <a:spcPts val="500"/>
+              </a:spcBef>
+              <a:buFont typeface="Arial" panose="020B0604020202020204" pitchFamily="34" charset="0"/>
+              <a:buChar char="•"/>
+              <a:defRPr sz="1800" kern="1200">
+                <a:solidFill>
+                  <a:schemeClr val="tx1"/>
+                </a:solidFill>
+                <a:latin typeface="+mn-lt"/>
+                <a:ea typeface="+mn-ea"/>
+                <a:cs typeface="+mn-cs"/>
+              </a:defRPr>
+            </a:lvl5pPr>
+            <a:lvl6pPr marL="2514600" indent="-228600" algn="l" defTabSz="914400" rtl="0" eaLnBrk="1" latinLnBrk="0" hangingPunct="1">
+              <a:lnSpc>
+                <a:spcPct val="90000"/>
+              </a:lnSpc>
+              <a:spcBef>
+                <a:spcPts val="500"/>
+              </a:spcBef>
+              <a:buFont typeface="Arial" panose="020B0604020202020204" pitchFamily="34" charset="0"/>
+              <a:buChar char="•"/>
+              <a:defRPr sz="1800" kern="1200">
+                <a:solidFill>
+                  <a:schemeClr val="tx1"/>
+                </a:solidFill>
+                <a:latin typeface="+mn-lt"/>
+                <a:ea typeface="+mn-ea"/>
+                <a:cs typeface="+mn-cs"/>
+              </a:defRPr>
+            </a:lvl6pPr>
+            <a:lvl7pPr marL="2971800" indent="-228600" algn="l" defTabSz="914400" rtl="0" eaLnBrk="1" latinLnBrk="0" hangingPunct="1">
+              <a:lnSpc>
+                <a:spcPct val="90000"/>
+              </a:lnSpc>
+              <a:spcBef>
+                <a:spcPts val="500"/>
+              </a:spcBef>
+              <a:buFont typeface="Arial" panose="020B0604020202020204" pitchFamily="34" charset="0"/>
+              <a:buChar char="•"/>
+              <a:defRPr sz="1800" kern="1200">
+                <a:solidFill>
+                  <a:schemeClr val="tx1"/>
+                </a:solidFill>
+                <a:latin typeface="+mn-lt"/>
+                <a:ea typeface="+mn-ea"/>
+                <a:cs typeface="+mn-cs"/>
+              </a:defRPr>
+            </a:lvl7pPr>
+            <a:lvl8pPr marL="3429000" indent="-228600" algn="l" defTabSz="914400" rtl="0" eaLnBrk="1" latinLnBrk="0" hangingPunct="1">
+              <a:lnSpc>
+                <a:spcPct val="90000"/>
+              </a:lnSpc>
+              <a:spcBef>
+                <a:spcPts val="500"/>
+              </a:spcBef>
+              <a:buFont typeface="Arial" panose="020B0604020202020204" pitchFamily="34" charset="0"/>
+              <a:buChar char="•"/>
+              <a:defRPr sz="1800" kern="1200">
+                <a:solidFill>
+                  <a:schemeClr val="tx1"/>
+                </a:solidFill>
+                <a:latin typeface="+mn-lt"/>
+                <a:ea typeface="+mn-ea"/>
+                <a:cs typeface="+mn-cs"/>
+              </a:defRPr>
+            </a:lvl8pPr>
+            <a:lvl9pPr marL="3886200" indent="-228600" algn="l" defTabSz="914400" rtl="0" eaLnBrk="1" latinLnBrk="0" hangingPunct="1">
+              <a:lnSpc>
+                <a:spcPct val="90000"/>
+              </a:lnSpc>
+              <a:spcBef>
+                <a:spcPts val="500"/>
+              </a:spcBef>
+              <a:buFont typeface="Arial" panose="020B0604020202020204" pitchFamily="34" charset="0"/>
+              <a:buChar char="•"/>
+              <a:defRPr sz="1800" kern="1200">
+                <a:solidFill>
+                  <a:schemeClr val="tx1"/>
+                </a:solidFill>
+                <a:latin typeface="+mn-lt"/>
+                <a:ea typeface="+mn-ea"/>
+                <a:cs typeface="+mn-cs"/>
+              </a:defRPr>
+            </a:lvl9pPr>
+          </a:lstStyle>
+          <a:p>
+            <a:pPr marL="0" indent="0">
+              <a:buNone/>
+            </a:pPr>
+            <a:r>
+              <a:rPr lang="en-US" b="1"/>
+              <a:t>pancak2 subroutine</a:t>
+            </a:r>
+          </a:p>
+        </p:txBody>
+      </p:sp>
+    </p:spTree>
+    <p:extLst>
+      <p:ext uri="{BB962C8B-B14F-4D97-AF65-F5344CB8AC3E}">
+        <p14:creationId xmlns:p14="http://schemas.microsoft.com/office/powerpoint/2010/main" val="1959670235"/>
       </p:ext>
     </p:extLst>
   </p:cSld>

</xml_diff>

<commit_message>
- more detailed description of pre format - differences between cur and smt format in order of Euler angle reporting documented
</commit_message>
<xml_diff>
--- a/people/mbonisch/pre dat file format.pptx
+++ b/people/mbonisch/pre dat file format.pptx
@@ -12,7 +12,7 @@
     <p:handoutMasterId r:id="rId8"/>
   </p:handoutMasterIdLst>
   <p:sldIdLst>
-    <p:sldId id="392" r:id="rId3"/>
+    <p:sldId id="402" r:id="rId3"/>
     <p:sldId id="399" r:id="rId4"/>
     <p:sldId id="401" r:id="rId5"/>
     <p:sldId id="397" r:id="rId6"/>
@@ -217,7 +217,7 @@
               <a:rPr lang="nl-NL" smtClean="0">
                 <a:latin typeface="Arial" panose="020B0604020202020204" pitchFamily="34" charset="0"/>
               </a:rPr>
-              <a:t>23-1-2021</a:t>
+              <a:t>9-2-2021</a:t>
             </a:fld>
             <a:endParaRPr lang="nl-NL">
               <a:latin typeface="Arial" panose="020B0604020202020204" pitchFamily="34" charset="0"/>
@@ -395,7 +395,7 @@
             <a:fld id="{23C66214-DB21-4647-B5DA-0D17CA592867}" type="datetimeFigureOut">
               <a:rPr lang="nl-NL" smtClean="0"/>
               <a:pPr/>
-              <a:t>23-1-2021</a:t>
+              <a:t>9-2-2021</a:t>
             </a:fld>
             <a:endParaRPr lang="nl-NL"/>
           </a:p>
@@ -1401,7 +1401,7 @@
           <a:p>
             <a:fld id="{6C117EB3-0723-4C33-A2DC-6917C9CA571A}" type="datetime1">
               <a:rPr lang="nl-BE" smtClean="0"/>
-              <a:t>23/01/2021</a:t>
+              <a:t>9/02/2021</a:t>
             </a:fld>
             <a:endParaRPr lang="nl-NL"/>
           </a:p>
@@ -1684,7 +1684,7 @@
           <a:p>
             <a:fld id="{199819D0-E997-4D10-8966-002558C5432F}" type="datetime1">
               <a:rPr lang="nl-BE" smtClean="0"/>
-              <a:t>23/01/2021</a:t>
+              <a:t>9/02/2021</a:t>
             </a:fld>
             <a:endParaRPr lang="nl-NL"/>
           </a:p>
@@ -2014,7 +2014,7 @@
           <a:p>
             <a:fld id="{8BFC36D0-E188-499B-A063-E30C52BBA65B}" type="datetime1">
               <a:rPr lang="nl-BE" smtClean="0"/>
-              <a:t>23/01/2021</a:t>
+              <a:t>9/02/2021</a:t>
             </a:fld>
             <a:endParaRPr lang="nl-NL"/>
           </a:p>
@@ -2336,7 +2336,7 @@
           <a:p>
             <a:fld id="{30760969-739A-495B-9AC8-9E83DBD19472}" type="datetime1">
               <a:rPr lang="nl-BE" smtClean="0"/>
-              <a:t>23/01/2021</a:t>
+              <a:t>9/02/2021</a:t>
             </a:fld>
             <a:endParaRPr lang="nl-NL" dirty="0"/>
           </a:p>
@@ -2657,7 +2657,7 @@
           <a:p>
             <a:fld id="{6223A32B-624A-4D19-87A0-E1B3FD383FFA}" type="datetime1">
               <a:rPr lang="nl-BE" smtClean="0"/>
-              <a:t>23/01/2021</a:t>
+              <a:t>9/02/2021</a:t>
             </a:fld>
             <a:endParaRPr lang="nl-NL" dirty="0"/>
           </a:p>
@@ -2799,7 +2799,7 @@
           <a:p>
             <a:fld id="{715776D5-6471-4EFF-BEAC-785903B7FED9}" type="datetime1">
               <a:rPr lang="nl-BE" smtClean="0"/>
-              <a:t>23/01/2021</a:t>
+              <a:t>9/02/2021</a:t>
             </a:fld>
             <a:endParaRPr lang="nl-NL"/>
           </a:p>
@@ -3283,7 +3283,7 @@
           <a:p>
             <a:fld id="{AD85EAB7-456F-4852-B075-588A4BB01E68}" type="datetime1">
               <a:rPr lang="nl-BE" smtClean="0"/>
-              <a:t>23/01/2021</a:t>
+              <a:t>9/02/2021</a:t>
             </a:fld>
             <a:endParaRPr lang="nl-NL" dirty="0"/>
           </a:p>
@@ -3404,7 +3404,7 @@
           <a:p>
             <a:fld id="{145893D8-4D6A-4159-B2D6-5CAAABFF1A22}" type="datetime1">
               <a:rPr lang="nl-BE" smtClean="0"/>
-              <a:t>23/01/2021</a:t>
+              <a:t>9/02/2021</a:t>
             </a:fld>
             <a:endParaRPr lang="nl-NL"/>
           </a:p>
@@ -3525,7 +3525,7 @@
           <a:p>
             <a:fld id="{5D11006A-A638-4A45-BEF9-2F5A607B99F5}" type="datetime1">
               <a:rPr lang="nl-BE" smtClean="0"/>
-              <a:t>23/01/2021</a:t>
+              <a:t>9/02/2021</a:t>
             </a:fld>
             <a:endParaRPr lang="nl-NL"/>
           </a:p>
@@ -3709,7 +3709,7 @@
           <a:p>
             <a:fld id="{449E52BB-B06C-4FE4-BEA7-7AF30AE8D9B1}" type="datetime1">
               <a:rPr lang="nl-BE" smtClean="0"/>
-              <a:t>23/01/2021</a:t>
+              <a:t>9/02/2021</a:t>
             </a:fld>
             <a:endParaRPr lang="nl-NL" dirty="0"/>
           </a:p>
@@ -3996,7 +3996,7 @@
             <a:fld id="{9EB15C0D-7927-40B6-88B8-DB26DAC0C328}" type="datetime1">
               <a:rPr lang="nl-BE" smtClean="0"/>
               <a:pPr/>
-              <a:t>23/01/2021</a:t>
+              <a:t>9/02/2021</a:t>
             </a:fld>
             <a:endParaRPr lang="nl-NL" dirty="0"/>
           </a:p>
@@ -4640,7 +4640,7 @@
             <a:fld id="{16C7DC62-5684-4D3E-A4B3-94058A773A6B}" type="datetime1">
               <a:rPr lang="nl-BE" smtClean="0"/>
               <a:pPr/>
-              <a:t>23/01/2021</a:t>
+              <a:t>9/02/2021</a:t>
             </a:fld>
             <a:endParaRPr lang="nl-NL" dirty="0"/>
           </a:p>
@@ -5266,8 +5266,8 @@
         </p:nvSpPr>
         <p:spPr>
           <a:xfrm>
-            <a:off x="1946802" y="1690624"/>
-            <a:ext cx="5463355" cy="1569660"/>
+            <a:off x="3011782" y="2427843"/>
+            <a:ext cx="2977098" cy="1077218"/>
           </a:xfrm>
           <a:prstGeom prst="rect">
             <a:avLst/>
@@ -5298,28 +5298,14 @@
             <a:pPr algn="ctr"/>
             <a:r>
               <a:rPr lang="en-US" sz="1600" b="1"/>
-              <a:t>each row is vector-formatted</a:t>
+              <a:t>symmetric part</a:t>
             </a:r>
           </a:p>
           <a:p>
             <a:pPr algn="ctr"/>
             <a:r>
               <a:rPr lang="en-US" sz="1600" b="1"/>
-              <a:t>symmetric part of Schmid tensor</a:t>
-            </a:r>
-          </a:p>
-          <a:p>
-            <a:pPr algn="ctr"/>
-            <a:r>
-              <a:rPr lang="en-US" sz="1600" b="1"/>
-              <a:t>(5 independent components);</a:t>
-            </a:r>
-          </a:p>
-          <a:p>
-            <a:pPr algn="ctr"/>
-            <a:r>
-              <a:rPr lang="en-US" sz="1600" b="1"/>
-              <a:t>all deformation systems, first slip systems, then twins</a:t>
+              <a:t>(5 independent components)</a:t>
             </a:r>
           </a:p>
         </p:txBody>
@@ -5392,8 +5378,8 @@
         </p:nvSpPr>
         <p:spPr>
           <a:xfrm>
-            <a:off x="7440459" y="1678453"/>
-            <a:ext cx="3826689" cy="1569660"/>
+            <a:off x="7681494" y="2415672"/>
+            <a:ext cx="2988319" cy="1077218"/>
           </a:xfrm>
           <a:prstGeom prst="rect">
             <a:avLst/>
@@ -5424,14 +5410,7 @@
             <a:pPr algn="ctr"/>
             <a:r>
               <a:rPr lang="en-US" sz="1600" b="1"/>
-              <a:t>each row is vector-formatted</a:t>
-            </a:r>
-          </a:p>
-          <a:p>
-            <a:pPr algn="ctr"/>
-            <a:r>
-              <a:rPr lang="en-US" sz="1600" b="1"/>
-              <a:t>anti-symmetric part of Schmid tensor</a:t>
+              <a:t>anti-symmetric part</a:t>
             </a:r>
           </a:p>
           <a:p>
@@ -5439,13 +5418,6 @@
             <a:r>
               <a:rPr lang="en-US" sz="1600" b="1"/>
               <a:t>(3 independent components)</a:t>
-            </a:r>
-          </a:p>
-          <a:p>
-            <a:pPr algn="ctr"/>
-            <a:r>
-              <a:rPr lang="en-US" sz="1600" b="1"/>
-              <a:t>all deformation systems</a:t>
             </a:r>
           </a:p>
         </p:txBody>
@@ -5688,8 +5660,8 @@
         </p:nvSpPr>
         <p:spPr>
           <a:xfrm>
-            <a:off x="2715882" y="4872301"/>
-            <a:ext cx="4584909" cy="830997"/>
+            <a:off x="2318647" y="4872301"/>
+            <a:ext cx="5379382" cy="1169551"/>
           </a:xfrm>
           <a:prstGeom prst="rect">
             <a:avLst/>
@@ -5701,7 +5673,7 @@
           </a:solidFill>
         </p:spPr>
         <p:txBody>
-          <a:bodyPr wrap="none" rtlCol="0">
+          <a:bodyPr wrap="square" rtlCol="0">
             <a:spAutoFit/>
           </a:bodyPr>
           <a:lstStyle/>
@@ -5721,6 +5693,13 @@
             <a:r>
               <a:rPr lang="en-US" sz="1600" b="1"/>
               <a:t>each row is matrix to calc. orientation of twin</a:t>
+            </a:r>
+          </a:p>
+          <a:p>
+            <a:pPr algn="ctr"/>
+            <a:r>
+              <a:rPr lang="en-US" sz="1100"/>
+              <a:t>(see subroutine DeformationMechanismData_completeFromDATformat in module altayDeformationMechanismfor its definition)</a:t>
             </a:r>
           </a:p>
         </p:txBody>
@@ -6283,7 +6262,7 @@
           <p:cNvPr id="25" name="TextBox 24">
             <a:extLst>
               <a:ext uri="{FF2B5EF4-FFF2-40B4-BE49-F238E27FC236}">
-                <a16:creationId xmlns:a16="http://schemas.microsoft.com/office/drawing/2014/main" id="{FC916DC2-DB32-40AD-AAA4-0A6EE6E3843B}"/>
+                <a16:creationId xmlns:a16="http://schemas.microsoft.com/office/drawing/2014/main" id="{AE30775D-E910-4C0A-A7AA-A45630B31081}"/>
               </a:ext>
             </a:extLst>
           </p:cNvPr>
@@ -6292,13 +6271,17 @@
         </p:nvSpPr>
         <p:spPr>
           <a:xfrm>
-            <a:off x="8570151" y="234026"/>
-            <a:ext cx="3049233" cy="523220"/>
+            <a:off x="4500331" y="1162141"/>
+            <a:ext cx="5105885" cy="1077218"/>
           </a:xfrm>
           <a:prstGeom prst="rect">
             <a:avLst/>
           </a:prstGeom>
-          <a:noFill/>
+          <a:solidFill>
+            <a:schemeClr val="bg1">
+              <a:alpha val="60000"/>
+            </a:schemeClr>
+          </a:solidFill>
         </p:spPr>
         <p:txBody>
           <a:bodyPr wrap="none" rtlCol="0">
@@ -6306,15 +6289,72 @@
           </a:bodyPr>
           <a:lstStyle/>
           <a:p>
+            <a:pPr algn="ctr"/>
+            <a:r>
+              <a:rPr lang="en-US" sz="1600" b="1"/>
+              <a:t>each row is vector-formatted</a:t>
+            </a:r>
+          </a:p>
+          <a:p>
+            <a:pPr algn="ctr"/>
+            <a:r>
+              <a:rPr lang="en-US" sz="1600" b="1"/>
+              <a:t>symmetric &amp; antisymmetric part of Schmid tensor </a:t>
+            </a:r>
+          </a:p>
+          <a:p>
+            <a:pPr algn="ctr"/>
+            <a:r>
+              <a:rPr lang="en-US" sz="1600" b="1"/>
+              <a:t>(i.e. of normalized velocity gradient);</a:t>
+            </a:r>
+          </a:p>
+          <a:p>
+            <a:pPr algn="ctr"/>
+            <a:r>
+              <a:rPr lang="en-US" sz="1600" b="1"/>
+              <a:t>all deformation systems: first slips, then twins</a:t>
+            </a:r>
+          </a:p>
+        </p:txBody>
+      </p:sp>
+      <p:sp>
+        <p:nvSpPr>
+          <p:cNvPr id="26" name="TextBox 25">
+            <a:extLst>
+              <a:ext uri="{FF2B5EF4-FFF2-40B4-BE49-F238E27FC236}">
+                <a16:creationId xmlns:a16="http://schemas.microsoft.com/office/drawing/2014/main" id="{FF174075-F7CD-406A-BE02-52E13571FA5B}"/>
+              </a:ext>
+            </a:extLst>
+          </p:cNvPr>
+          <p:cNvSpPr txBox="1"/>
+          <p:nvPr/>
+        </p:nvSpPr>
+        <p:spPr>
+          <a:xfrm>
+            <a:off x="8570151" y="102311"/>
+            <a:ext cx="3621849" cy="738664"/>
+          </a:xfrm>
+          <a:prstGeom prst="rect">
+            <a:avLst/>
+          </a:prstGeom>
+          <a:noFill/>
+        </p:spPr>
+        <p:txBody>
+          <a:bodyPr wrap="square" rtlCol="0">
+            <a:spAutoFit/>
+          </a:bodyPr>
+          <a:lstStyle/>
+          <a:p>
             <a:r>
               <a:rPr lang="en-US" sz="1400"/>
-              <a:t>See the pancak2 subroutine for how</a:t>
+              <a:t>See subroutine pancak2 and module altayDeformationMechanism for how</a:t>
             </a:r>
           </a:p>
           <a:p>
             <a:r>
               <a:rPr lang="en-US" sz="1400"/>
-              <a:t>these matrices are used!</a:t>
+              <a:t>these matrices are created and used!</a:t>
             </a:r>
           </a:p>
         </p:txBody>
@@ -6322,7 +6362,7 @@
     </p:spTree>
     <p:extLst>
       <p:ext uri="{BB962C8B-B14F-4D97-AF65-F5344CB8AC3E}">
-        <p14:creationId xmlns:p14="http://schemas.microsoft.com/office/powerpoint/2010/main" val="1348514435"/>
+        <p14:creationId xmlns:p14="http://schemas.microsoft.com/office/powerpoint/2010/main" val="3858658540"/>
       </p:ext>
     </p:extLst>
   </p:cSld>
@@ -8601,8 +8641,8 @@
           </a:p>
         </p:txBody>
       </p:sp>
-      <mc:AlternateContent xmlns:mc="http://schemas.openxmlformats.org/markup-compatibility/2006">
-        <mc:Choice xmlns:a14="http://schemas.microsoft.com/office/drawing/2010/main" Requires="a14">
+      <mc:AlternateContent xmlns:mc="http://schemas.openxmlformats.org/markup-compatibility/2006" xmlns:a14="http://schemas.microsoft.com/office/drawing/2010/main">
+        <mc:Choice Requires="a14">
           <p:sp>
             <p:nvSpPr>
               <p:cNvPr id="8" name="TextBox 7">
@@ -8720,13 +8760,7 @@
                                   <a:rPr lang="en-US" b="0" i="1" smtClean="0">
                                     <a:latin typeface="Cambria Math" panose="02040503050406030204" pitchFamily="18" charset="0"/>
                                   </a:rPr>
-                                  <m:t>𝑅𝐿𝑋</m:t>
-                                </m:r>
-                                <m:r>
-                                  <a:rPr lang="en-US" b="0" i="1" smtClean="0">
-                                    <a:latin typeface="Cambria Math" panose="02040503050406030204" pitchFamily="18" charset="0"/>
-                                  </a:rPr>
-                                  <m:t>𝑔</m:t>
+                                  <m:t>𝑅𝐿𝑋𝑔</m:t>
                                 </m:r>
                                 <m:r>
                                   <a:rPr lang="en-US" b="0" i="1" smtClean="0">
@@ -8750,13 +8784,7 @@
                                   <a:rPr lang="en-US" b="0" i="1" smtClean="0">
                                     <a:latin typeface="Cambria Math" panose="02040503050406030204" pitchFamily="18" charset="0"/>
                                   </a:rPr>
-                                  <m:t>𝐴</m:t>
-                                </m:r>
-                                <m:r>
-                                  <a:rPr lang="en-US" b="0" i="1" smtClean="0">
-                                    <a:latin typeface="Cambria Math" panose="02040503050406030204" pitchFamily="18" charset="0"/>
-                                  </a:rPr>
-                                  <m:t>𝑔</m:t>
+                                  <m:t>𝐴𝑔</m:t>
                                 </m:r>
                                 <m:r>
                                   <a:rPr lang="en-US" b="0" i="1" smtClean="0">
@@ -8770,13 +8798,7 @@
                                   <a:rPr lang="en-US" b="0" i="1" smtClean="0">
                                     <a:latin typeface="Cambria Math" panose="02040503050406030204" pitchFamily="18" charset="0"/>
                                   </a:rPr>
-                                  <m:t>𝑅𝐿𝑋</m:t>
-                                </m:r>
-                                <m:r>
-                                  <a:rPr lang="en-US" b="0" i="1" smtClean="0">
-                                    <a:latin typeface="Cambria Math" panose="02040503050406030204" pitchFamily="18" charset="0"/>
-                                  </a:rPr>
-                                  <m:t>𝑔</m:t>
+                                  <m:t>𝑅𝐿𝑋𝑔</m:t>
                                 </m:r>
                                 <m:r>
                                   <a:rPr lang="en-US" b="0" i="1" smtClean="0">
@@ -8797,7 +8819,7 @@
             </p:txBody>
           </p:sp>
         </mc:Choice>
-        <mc:Fallback>
+        <mc:Fallback xmlns="">
           <p:sp>
             <p:nvSpPr>
               <p:cNvPr id="8" name="TextBox 7">
@@ -9032,8 +9054,8 @@
           </a:p>
         </p:txBody>
       </p:sp>
-      <mc:AlternateContent xmlns:mc="http://schemas.openxmlformats.org/markup-compatibility/2006">
-        <mc:Choice xmlns:a14="http://schemas.microsoft.com/office/drawing/2010/main" Requires="a14">
+      <mc:AlternateContent xmlns:mc="http://schemas.openxmlformats.org/markup-compatibility/2006" xmlns:a14="http://schemas.microsoft.com/office/drawing/2010/main">
+        <mc:Choice Requires="a14">
           <p:sp>
             <p:nvSpPr>
               <p:cNvPr id="22" name="TextBox 21">
@@ -9117,7 +9139,7 @@
             </p:txBody>
           </p:sp>
         </mc:Choice>
-        <mc:Fallback>
+        <mc:Fallback xmlns="">
           <p:sp>
             <p:nvSpPr>
               <p:cNvPr id="22" name="TextBox 21">

</xml_diff>